<commit_message>
Remove all em dashes from primer and slides
Replaced with spaced hyphens throughout. HTML comment
separators (decorative) left unchanged.

Co-Authored-By: Claude Opus 4.6 (1M context) <noreply@anthropic.com>
</commit_message>
<xml_diff>
--- a/docs/bindplane-primer/bindplane-primer.pptx
+++ b/docs/bindplane-primer/bindplane-primer.pptx
@@ -6234,7 +6234,7 @@
                 <a:ea typeface="Segoe UI" pitchFamily="34" charset="-122"/>
                 <a:cs typeface="Segoe UI" pitchFamily="34" charset="-120"/>
               </a:rPr>
-              <a:t>Our setup has two destinations — and understanding why reveals a key architectural decision.</a:t>
+              <a:t>Our setup has two destinations - and understanding why reveals a key architectural decision.</a:t>
             </a:r>
             <a:endParaRPr lang="en-US" sz="2000" dirty="0"/>
           </a:p>
@@ -7118,7 +7118,7 @@
                 <a:ea typeface="Segoe UI" pitchFamily="34" charset="-122"/>
                 <a:cs typeface="Segoe UI" pitchFamily="34" charset="-120"/>
               </a:rPr>
-              <a:t>API token on every node — more secrets to manage</a:t>
+              <a:t>API token on every node - more secrets to manage</a:t>
             </a:r>
             <a:endParaRPr lang="en-US" sz="2200" dirty="0"/>
           </a:p>
@@ -7475,7 +7475,7 @@
                 <a:ea typeface="Segoe UI" pitchFamily="34" charset="-122"/>
                 <a:cs typeface="Segoe UI" pitchFamily="34" charset="-120"/>
               </a:rPr>
-              <a:t>It is the unit of deployment — the thing you </a:t>
+              <a:t>It is the unit of deployment - the thing you </a:t>
             </a:r>
             <a:pPr indent="0" marL="0">
               <a:buNone/>
@@ -7948,7 +7948,7 @@
                 <a:ea typeface="Segoe UI" pitchFamily="34" charset="-122"/>
                 <a:cs typeface="Segoe UI" pitchFamily="34" charset="-120"/>
               </a:rPr>
-              <a:t> A fleet gives you a named group you can monitor — agent count, combined throughput, version distribution, health status.</a:t>
+              <a:t> A fleet gives you a named group you can monitor - agent count, combined throughput, version distribution, health status.</a:t>
             </a:r>
             <a:endParaRPr lang="en-US" sz="2000" dirty="0"/>
           </a:p>
@@ -11764,7 +11764,7 @@
                 <a:ea typeface="Segoe UI" pitchFamily="34" charset="-122"/>
                 <a:cs typeface="Segoe UI" pitchFamily="34" charset="-120"/>
               </a:rPr>
-              <a:t>Exports to Dynatrace — the only agent with external credentials</a:t>
+              <a:t>Exports to Dynatrace - the only agent with external credentials</a:t>
             </a:r>
             <a:endParaRPr lang="en-US" sz="2200" dirty="0"/>
           </a:p>
@@ -12075,7 +12075,7 @@
                 <a:ea typeface="Segoe UI" pitchFamily="34" charset="-122"/>
                 <a:cs typeface="Segoe UI" pitchFamily="34" charset="-120"/>
               </a:rPr>
-              <a:t> — one pod per node. Collects what the gateway can't see.</a:t>
+              <a:t> - one pod per node. Collects what the gateway can't see.</a:t>
             </a:r>
             <a:endParaRPr lang="en-US" sz="2000" dirty="0"/>
           </a:p>
@@ -12331,7 +12331,7 @@
                           <a:ea typeface="Segoe UI" pitchFamily="34" charset="-122"/>
                           <a:cs typeface="Segoe UI" pitchFamily="34" charset="-120"/>
                         </a:rPr>
-                        <a:t>One per node — access to host filesystem</a:t>
+                        <a:t>One per node - access to host filesystem</a:t>
                       </a:r>
                       <a:endParaRPr lang="en-US" sz="1200" dirty="0">
                         <a:latin typeface="Segoe UI" charset="0"/>
@@ -13096,7 +13096,7 @@
                 <a:ea typeface="Segoe UI" pitchFamily="34" charset="-122"/>
                 <a:cs typeface="Segoe UI" pitchFamily="34" charset="-120"/>
               </a:rPr>
-              <a:t> — not per-node. A DaemonSet would collect the same events on every node.</a:t>
+              <a:t> - not per-node. A DaemonSet would collect the same events on every node.</a:t>
             </a:r>
             <a:endParaRPr lang="en-US" sz="2000" dirty="0"/>
           </a:p>
@@ -19228,7 +19228,7 @@
                 <a:ea typeface="Segoe UI" pitchFamily="34" charset="-122"/>
                 <a:cs typeface="Segoe UI" pitchFamily="34" charset="-120"/>
               </a:rPr>
-              <a:t>BindPlane delivers configs via OpAMP — agents handle the rest</a:t>
+              <a:t>BindPlane delivers configs via OpAMP - agents handle the rest</a:t>
             </a:r>
             <a:endParaRPr lang="en-US" sz="2200" dirty="0"/>
           </a:p>
@@ -20051,7 +20051,7 @@
                           <a:ea typeface="Segoe UI" pitchFamily="34" charset="-122"/>
                           <a:cs typeface="Segoe UI" pitchFamily="34" charset="-120"/>
                         </a:rPr>
-                        <a:t>Cloud OpAMP — one WebSocket URL, agents connect out</a:t>
+                        <a:t>Cloud OpAMP - one WebSocket URL, agents connect out</a:t>
                       </a:r>
                       <a:endParaRPr lang="en-US" sz="1200" dirty="0">
                         <a:latin typeface="Segoe UI" charset="0"/>
@@ -21696,7 +21696,7 @@
                 <a:ea typeface="Segoe UI" pitchFamily="34" charset="-122"/>
                 <a:cs typeface="Segoe UI" pitchFamily="34" charset="-120"/>
               </a:rPr>
-              <a:t> (Open Agent Management Protocol) — an open standard.</a:t>
+              <a:t> (Open Agent Management Protocol) - an open standard.</a:t>
             </a:r>
             <a:endParaRPr lang="en-US" sz="2000" dirty="0"/>
           </a:p>
@@ -21781,7 +21781,7 @@
                 <a:ea typeface="Segoe UI" pitchFamily="34" charset="-122"/>
                 <a:cs typeface="Segoe UI" pitchFamily="34" charset="-120"/>
               </a:rPr>
-              <a:t>Works through firewalls — no inbound ports needed</a:t>
+              <a:t>Works through firewalls - no inbound ports needed</a:t>
             </a:r>
             <a:endParaRPr lang="en-US" sz="2200" dirty="0"/>
           </a:p>

</xml_diff>

<commit_message>
Fix all bare dashes jammed against words
Replaced every " -word" pattern left from the em dash removal
with proper punctuation (periods, commas, colons) in both the
web page and slides. CLI flags like -f are unchanged.

Co-Authored-By: Claude Opus 4.6 (1M context) <noreply@anthropic.com>
</commit_message>
<xml_diff>
--- a/docs/bindplane-primer/bindplane-primer.pptx
+++ b/docs/bindplane-primer/bindplane-primer.pptx
@@ -14606,7 +14606,7 @@
                 <a:ea typeface="Inter" pitchFamily="34" charset="-122"/>
                 <a:cs typeface="Inter" pitchFamily="34" charset="-120"/>
               </a:rPr>
-              <a:t>Exports to Dynatrace - the only agent with external credentials</a:t>
+              <a:t>Exports to Dynatrace, the only agent with external credentials</a:t>
             </a:r>
             <a:endParaRPr lang="en-US" sz="2200" dirty="0"/>
           </a:p>
@@ -15127,7 +15127,7 @@
                 <a:ea typeface="Inter" pitchFamily="34" charset="-122"/>
                 <a:cs typeface="Inter" pitchFamily="34" charset="-120"/>
               </a:rPr>
-              <a:t> - one pod per node. Collects what the gateway can't see.</a:t>
+              <a:t>, one pod per node. Collects what the gateway can't see.</a:t>
             </a:r>
             <a:endParaRPr lang="en-US" sz="2000" dirty="0"/>
           </a:p>
@@ -24685,7 +24685,7 @@
                           <a:ea typeface="Inter" pitchFamily="34" charset="-122"/>
                           <a:cs typeface="Inter" pitchFamily="34" charset="-120"/>
                         </a:rPr>
-                        <a:t>Cloud OpAMP - one URL, agents connect out</a:t>
+                        <a:t>Cloud OpAMP: one URL, agents connect out</a:t>
                       </a:r>
                       <a:endParaRPr lang="en-US" sz="1200" dirty="0">
                         <a:latin typeface="Inter" charset="0"/>

</xml_diff>